<commit_message>
v4: add Health KEY INSIGHT panel, pastel colors for ranking chart
- Added KEY INSIGHT panel to Health Component slide (slide 9)
  matching the style of Education and Employment slides
- Ranking chart (slide 6) now uses pastel teal (#7EBDC2) for
  above world avg and pastel salmon (#E8A09A) for below,
  distinct from all other colors in the deck

https://claude.ai/code/session_01NnNMYV5Wsqw6TZEg83HmV8
</commit_message>
<xml_diff>
--- a/EAP_HCI_Plus_2025_v4.pptx
+++ b/EAP_HCI_Plus_2025_v4.pptx
@@ -1927,14 +1927,14 @@
           </c:tx>
           <c:spPr>
             <a:solidFill>
-              <a:srgbClr val="2171B5"/>
+              <a:srgbClr val="7EBDC2"/>
             </a:solidFill>
           </c:spPr>
           <c:dPt>
             <c:idx val="0"/>
             <c:spPr>
               <a:solidFill>
-                <a:srgbClr val="C0392B"/>
+                <a:srgbClr val="E8A09A"/>
               </a:solidFill>
             </c:spPr>
           </c:dPt>
@@ -1942,7 +1942,7 @@
             <c:idx val="1"/>
             <c:spPr>
               <a:solidFill>
-                <a:srgbClr val="C0392B"/>
+                <a:srgbClr val="E8A09A"/>
               </a:solidFill>
             </c:spPr>
           </c:dPt>
@@ -1950,7 +1950,7 @@
             <c:idx val="2"/>
             <c:spPr>
               <a:solidFill>
-                <a:srgbClr val="C0392B"/>
+                <a:srgbClr val="E8A09A"/>
               </a:solidFill>
             </c:spPr>
           </c:dPt>
@@ -1958,7 +1958,7 @@
             <c:idx val="3"/>
             <c:spPr>
               <a:solidFill>
-                <a:srgbClr val="C0392B"/>
+                <a:srgbClr val="E8A09A"/>
               </a:solidFill>
             </c:spPr>
           </c:dPt>
@@ -1966,7 +1966,7 @@
             <c:idx val="4"/>
             <c:spPr>
               <a:solidFill>
-                <a:srgbClr val="C0392B"/>
+                <a:srgbClr val="E8A09A"/>
               </a:solidFill>
             </c:spPr>
           </c:dPt>
@@ -1974,7 +1974,7 @@
             <c:idx val="5"/>
             <c:spPr>
               <a:solidFill>
-                <a:srgbClr val="C0392B"/>
+                <a:srgbClr val="E8A09A"/>
               </a:solidFill>
             </c:spPr>
           </c:dPt>
@@ -1982,7 +1982,7 @@
             <c:idx val="6"/>
             <c:spPr>
               <a:solidFill>
-                <a:srgbClr val="C0392B"/>
+                <a:srgbClr val="E8A09A"/>
               </a:solidFill>
             </c:spPr>
           </c:dPt>
@@ -1990,7 +1990,7 @@
             <c:idx val="7"/>
             <c:spPr>
               <a:solidFill>
-                <a:srgbClr val="C0392B"/>
+                <a:srgbClr val="E8A09A"/>
               </a:solidFill>
             </c:spPr>
           </c:dPt>
@@ -1998,7 +1998,7 @@
             <c:idx val="8"/>
             <c:spPr>
               <a:solidFill>
-                <a:srgbClr val="C0392B"/>
+                <a:srgbClr val="E8A09A"/>
               </a:solidFill>
             </c:spPr>
           </c:dPt>
@@ -2006,7 +2006,7 @@
             <c:idx val="9"/>
             <c:spPr>
               <a:solidFill>
-                <a:srgbClr val="C0392B"/>
+                <a:srgbClr val="E8A09A"/>
               </a:solidFill>
             </c:spPr>
           </c:dPt>
@@ -2014,7 +2014,7 @@
             <c:idx val="10"/>
             <c:spPr>
               <a:solidFill>
-                <a:srgbClr val="C0392B"/>
+                <a:srgbClr val="E8A09A"/>
               </a:solidFill>
             </c:spPr>
           </c:dPt>
@@ -2022,7 +2022,7 @@
             <c:idx val="11"/>
             <c:spPr>
               <a:solidFill>
-                <a:srgbClr val="C0392B"/>
+                <a:srgbClr val="E8A09A"/>
               </a:solidFill>
             </c:spPr>
           </c:dPt>
@@ -22082,7 +22082,7 @@
             <a:avLst/>
           </a:prstGeom>
           <a:solidFill>
-            <a:srgbClr val="2171B5"/>
+            <a:srgbClr val="7EBDC2"/>
           </a:solidFill>
           <a:ln>
             <a:noFill/>
@@ -22159,7 +22159,7 @@
             <a:avLst/>
           </a:prstGeom>
           <a:solidFill>
-            <a:srgbClr val="C0392B"/>
+            <a:srgbClr val="E8A09A"/>
           </a:solidFill>
           <a:ln>
             <a:noFill/>
@@ -23910,7 +23910,161 @@
       </p:sp>
       <p:sp>
         <p:nvSpPr>
-          <p:cNvPr id="30" name="Rectangle 29"/>
+          <p:cNvPr id="30" name="Rounded Rectangle 29"/>
+          <p:cNvSpPr/>
+          <p:nvPr/>
+        </p:nvSpPr>
+        <p:spPr>
+          <a:xfrm>
+            <a:off x="457200" y="4297680"/>
+            <a:ext cx="11247120" cy="1463040"/>
+          </a:xfrm>
+          <a:prstGeom prst="roundRect">
+            <a:avLst/>
+          </a:prstGeom>
+          <a:solidFill>
+            <a:srgbClr val="FFFFFF"/>
+          </a:solidFill>
+          <a:ln>
+            <a:noFill/>
+          </a:ln>
+        </p:spPr>
+        <p:style>
+          <a:lnRef idx="1">
+            <a:schemeClr val="accent1"/>
+          </a:lnRef>
+          <a:fillRef idx="3">
+            <a:schemeClr val="accent1"/>
+          </a:fillRef>
+          <a:effectRef idx="2">
+            <a:schemeClr val="accent1"/>
+          </a:effectRef>
+          <a:fontRef idx="minor">
+            <a:schemeClr val="lt1"/>
+          </a:fontRef>
+        </p:style>
+        <p:txBody>
+          <a:bodyPr rtlCol="0" anchor="ctr"/>
+          <a:lstStyle/>
+          <a:p>
+            <a:pPr algn="ctr"/>
+          </a:p>
+        </p:txBody>
+      </p:sp>
+      <p:sp>
+        <p:nvSpPr>
+          <p:cNvPr id="31" name="Rectangle 30"/>
+          <p:cNvSpPr/>
+          <p:nvPr/>
+        </p:nvSpPr>
+        <p:spPr>
+          <a:xfrm>
+            <a:off x="457200" y="4297680"/>
+            <a:ext cx="63500" cy="1463040"/>
+          </a:xfrm>
+          <a:prstGeom prst="rect">
+            <a:avLst/>
+          </a:prstGeom>
+          <a:solidFill>
+            <a:srgbClr val="2B4C7E"/>
+          </a:solidFill>
+          <a:ln>
+            <a:noFill/>
+          </a:ln>
+        </p:spPr>
+        <p:style>
+          <a:lnRef idx="1">
+            <a:schemeClr val="accent1"/>
+          </a:lnRef>
+          <a:fillRef idx="3">
+            <a:schemeClr val="accent1"/>
+          </a:fillRef>
+          <a:effectRef idx="2">
+            <a:schemeClr val="accent1"/>
+          </a:effectRef>
+          <a:fontRef idx="minor">
+            <a:schemeClr val="lt1"/>
+          </a:fontRef>
+        </p:style>
+        <p:txBody>
+          <a:bodyPr rtlCol="0" anchor="ctr"/>
+          <a:lstStyle/>
+          <a:p>
+            <a:pPr algn="ctr"/>
+          </a:p>
+        </p:txBody>
+      </p:sp>
+      <p:sp>
+        <p:nvSpPr>
+          <p:cNvPr id="32" name="TextBox 31"/>
+          <p:cNvSpPr txBox="1"/>
+          <p:nvPr/>
+        </p:nvSpPr>
+        <p:spPr>
+          <a:xfrm>
+            <a:off x="731520" y="4389120"/>
+            <a:ext cx="3657600" cy="228600"/>
+          </a:xfrm>
+          <a:prstGeom prst="rect">
+            <a:avLst/>
+          </a:prstGeom>
+          <a:noFill/>
+        </p:spPr>
+        <p:txBody>
+          <a:bodyPr wrap="square" anchor="t"/>
+          <a:lstStyle/>
+          <a:p>
+            <a:pPr algn="l">
+              <a:defRPr sz="1000" b="1">
+                <a:solidFill>
+                  <a:srgbClr val="2B4C7E"/>
+                </a:solidFill>
+                <a:latin typeface="Calibri"/>
+              </a:defRPr>
+            </a:pPr>
+            <a:r>
+              <a:t>KEY INSIGHT</a:t>
+            </a:r>
+          </a:p>
+        </p:txBody>
+      </p:sp>
+      <p:sp>
+        <p:nvSpPr>
+          <p:cNvPr id="33" name="TextBox 32"/>
+          <p:cNvSpPr txBox="1"/>
+          <p:nvPr/>
+        </p:nvSpPr>
+        <p:spPr>
+          <a:xfrm>
+            <a:off x="731520" y="4617720"/>
+            <a:ext cx="10515600" cy="1005840"/>
+          </a:xfrm>
+          <a:prstGeom prst="rect">
+            <a:avLst/>
+          </a:prstGeom>
+          <a:noFill/>
+        </p:spPr>
+        <p:txBody>
+          <a:bodyPr wrap="square" anchor="t"/>
+          <a:lstStyle/>
+          <a:p>
+            <a:pPr algn="l">
+              <a:defRPr sz="1000" b="0">
+                <a:solidFill>
+                  <a:srgbClr val="1A1A2E"/>
+                </a:solidFill>
+                <a:latin typeface="Calibri"/>
+              </a:defRPr>
+            </a:pPr>
+            <a:r>
+              <a:t>EAP's health score of 42.8 ranks 3rd among regions, just above the world average (42.6). Adult survival averages 85.3% — well above the global mean (81.5%) — and stunting rates are low (13.4%). Korea leads with 96.7% adult survival and 99.1% not-stunted. Pacific Island nations and some ASEAN economies remain below regional averages, presenting targeted opportunities for health investment.</a:t>
+            </a:r>
+          </a:p>
+        </p:txBody>
+      </p:sp>
+      <p:sp>
+        <p:nvSpPr>
+          <p:cNvPr id="34" name="Rectangle 33"/>
           <p:cNvSpPr/>
           <p:nvPr/>
         </p:nvSpPr>
@@ -23953,7 +24107,7 @@
       </p:sp>
       <p:sp>
         <p:nvSpPr>
-          <p:cNvPr id="31" name="TextBox 30"/>
+          <p:cNvPr id="35" name="TextBox 34"/>
           <p:cNvSpPr txBox="1"/>
           <p:nvPr/>
         </p:nvSpPr>
@@ -23987,7 +24141,7 @@
       </p:sp>
       <p:sp>
         <p:nvSpPr>
-          <p:cNvPr id="32" name="TextBox 31"/>
+          <p:cNvPr id="36" name="TextBox 35"/>
           <p:cNvSpPr txBox="1"/>
           <p:nvPr/>
         </p:nvSpPr>
@@ -24021,7 +24175,7 @@
       </p:sp>
       <p:sp>
         <p:nvSpPr>
-          <p:cNvPr id="33" name="TextBox 32"/>
+          <p:cNvPr id="37" name="TextBox 36"/>
           <p:cNvSpPr txBox="1"/>
           <p:nvPr/>
         </p:nvSpPr>

</xml_diff>